<commit_message>
Add SHAP bar chart to Slide 8 of presentation
Generated matplotlib SHAP-style horizontal bar chart showing top-10
features with green (toward) and red (away) colors, embedded directly
in the PPT via in-memory buffer.

Co-Authored-By: Claude Sonnet 4.6 <noreply@anthropic.com>
</commit_message>
<xml_diff>
--- a/IoT_Fingerprinting_Presentation_FINAL.pptx
+++ b/IoT_Fingerprinting_Presentation_FINAL.pptx
@@ -15632,16 +15632,40 @@
           </a:p>
         </p:txBody>
       </p:sp>
-      <p:sp>
-        <p:nvSpPr>
-          <p:cNvPr id="19" name="Rectangle 18"/>
+      <p:pic>
+        <p:nvPicPr>
+          <p:cNvPr id="19" name="Picture 18" descr="image.png"/>
+          <p:cNvPicPr>
+            <a:picLocks noChangeAspect="1"/>
+          </p:cNvPicPr>
+          <p:nvPr/>
+        </p:nvPicPr>
+        <p:blipFill>
+          <a:blip r:embed="rId2"/>
+          <a:stretch>
+            <a:fillRect/>
+          </a:stretch>
+        </p:blipFill>
+        <p:spPr>
+          <a:xfrm>
+            <a:off x="7863840" y="914400"/>
+            <a:ext cx="4114800" cy="2926080"/>
+          </a:xfrm>
+          <a:prstGeom prst="rect">
+            <a:avLst/>
+          </a:prstGeom>
+        </p:spPr>
+      </p:pic>
+      <p:sp>
+        <p:nvSpPr>
+          <p:cNvPr id="20" name="Rectangle 19"/>
           <p:cNvSpPr/>
           <p:nvPr/>
         </p:nvSpPr>
         <p:spPr>
           <a:xfrm>
-            <a:off x="8412480" y="960120"/>
-            <a:ext cx="3474720" cy="2286000"/>
+            <a:off x="7863840" y="3931920"/>
+            <a:ext cx="4114800" cy="2560320"/>
           </a:xfrm>
           <a:prstGeom prst="rect">
             <a:avLst/>
@@ -15677,14 +15701,14 @@
       </p:sp>
       <p:sp>
         <p:nvSpPr>
-          <p:cNvPr id="20" name="TextBox 19"/>
-          <p:cNvSpPr txBox="1"/>
-          <p:nvPr/>
-        </p:nvSpPr>
-        <p:spPr>
-          <a:xfrm>
-            <a:off x="8503920" y="1005840"/>
-            <a:ext cx="3291840" cy="365760"/>
+          <p:cNvPr id="21" name="TextBox 20"/>
+          <p:cNvSpPr txBox="1"/>
+          <p:nvPr/>
+        </p:nvSpPr>
+        <p:spPr>
+          <a:xfrm>
+            <a:off x="7955279" y="3977639"/>
+            <a:ext cx="3931920" cy="365760"/>
           </a:xfrm>
           <a:prstGeom prst="rect">
             <a:avLst/>
@@ -15699,7 +15723,7 @@
           <a:p>
             <a:pPr algn="ctr"/>
             <a:r>
-              <a:rPr sz="1400" b="1">
+              <a:rPr sz="1300" b="1">
                 <a:solidFill>
                   <a:srgbClr val="00D4FF"/>
                 </a:solidFill>
@@ -15711,14 +15735,14 @@
       </p:sp>
       <p:sp>
         <p:nvSpPr>
-          <p:cNvPr id="21" name="TextBox 20"/>
-          <p:cNvSpPr txBox="1"/>
-          <p:nvPr/>
-        </p:nvSpPr>
-        <p:spPr>
-          <a:xfrm>
-            <a:off x="8503920" y="1417320"/>
-            <a:ext cx="3291840" cy="1737360"/>
+          <p:cNvPr id="22" name="TextBox 21"/>
+          <p:cNvSpPr txBox="1"/>
+          <p:nvPr/>
+        </p:nvSpPr>
+        <p:spPr>
+          <a:xfrm>
+            <a:off x="7955279" y="4370832"/>
+            <a:ext cx="3931920" cy="2011680"/>
           </a:xfrm>
           <a:prstGeom prst="rect">
             <a:avLst/>

</xml_diff>

<commit_message>
Final PPT: add live demo URLs to Slides 10 and 11
Added Try live: https://mdghufran-iot-fingerprinting.hf.space/docs
banner to both demo slides so panel can test endpoints directly.

Co-Authored-By: Claude Sonnet 4.6 <noreply@anthropic.com>
</commit_message>
<xml_diff>
--- a/IoT_Fingerprinting_Presentation_FINAL.pptx
+++ b/IoT_Fingerprinting_Presentation_FINAL.pptx
@@ -5582,8 +5582,8 @@
         </p:nvSpPr>
         <p:spPr>
           <a:xfrm>
-            <a:off x="365760" y="5897880"/>
-            <a:ext cx="11430000" cy="411480"/>
+            <a:off x="365760" y="5577840"/>
+            <a:ext cx="11430000" cy="347472"/>
           </a:xfrm>
           <a:prstGeom prst="rect">
             <a:avLst/>
@@ -5604,6 +5604,83 @@
                 </a:solidFill>
               </a:rPr>
               <a:t>No hardware access. No credentials. No agent installed on any device.</a:t>
+            </a:r>
+          </a:p>
+        </p:txBody>
+      </p:sp>
+      <p:sp>
+        <p:nvSpPr>
+          <p:cNvPr id="55" name="Rectangle 54"/>
+          <p:cNvSpPr/>
+          <p:nvPr/>
+        </p:nvSpPr>
+        <p:spPr>
+          <a:xfrm>
+            <a:off x="365760" y="5989320"/>
+            <a:ext cx="11430000" cy="548640"/>
+          </a:xfrm>
+          <a:prstGeom prst="rect">
+            <a:avLst/>
+          </a:prstGeom>
+          <a:solidFill>
+            <a:srgbClr val="002040"/>
+          </a:solidFill>
+          <a:ln>
+            <a:noFill/>
+          </a:ln>
+        </p:spPr>
+        <p:style>
+          <a:lnRef idx="1">
+            <a:schemeClr val="accent1"/>
+          </a:lnRef>
+          <a:fillRef idx="3">
+            <a:schemeClr val="accent1"/>
+          </a:fillRef>
+          <a:effectRef idx="2">
+            <a:schemeClr val="accent1"/>
+          </a:effectRef>
+          <a:fontRef idx="minor">
+            <a:schemeClr val="lt1"/>
+          </a:fontRef>
+        </p:style>
+        <p:txBody>
+          <a:bodyPr rtlCol="0" anchor="ctr"/>
+          <a:lstStyle/>
+          <a:p>
+            <a:pPr algn="ctr"/>
+          </a:p>
+        </p:txBody>
+      </p:sp>
+      <p:sp>
+        <p:nvSpPr>
+          <p:cNvPr id="56" name="TextBox 55"/>
+          <p:cNvSpPr txBox="1"/>
+          <p:nvPr/>
+        </p:nvSpPr>
+        <p:spPr>
+          <a:xfrm>
+            <a:off x="457200" y="6016752"/>
+            <a:ext cx="11247120" cy="457200"/>
+          </a:xfrm>
+          <a:prstGeom prst="rect">
+            <a:avLst/>
+          </a:prstGeom>
+          <a:noFill/>
+        </p:spPr>
+        <p:txBody>
+          <a:bodyPr wrap="square">
+            <a:spAutoFit/>
+          </a:bodyPr>
+          <a:lstStyle/>
+          <a:p>
+            <a:pPr algn="ctr"/>
+            <a:r>
+              <a:rPr sz="1400" b="1">
+                <a:solidFill>
+                  <a:srgbClr val="00FF88"/>
+                </a:solidFill>
+              </a:rPr>
+              <a:t>Try live:  https://mdghufran-iot-fingerprinting.hf.space/docs  →  POST /fingerprint</a:t>
             </a:r>
           </a:p>
         </p:txBody>
@@ -6812,8 +6889,8 @@
         </p:nvSpPr>
         <p:spPr>
           <a:xfrm>
-            <a:off x="365760" y="5394960"/>
-            <a:ext cx="11430000" cy="502920"/>
+            <a:off x="365760" y="5212080"/>
+            <a:ext cx="11430000" cy="411480"/>
           </a:xfrm>
           <a:prstGeom prst="rect">
             <a:avLst/>
@@ -6855,8 +6932,8 @@
         </p:nvSpPr>
         <p:spPr>
           <a:xfrm>
-            <a:off x="457200" y="5422392"/>
-            <a:ext cx="11247120" cy="411480"/>
+            <a:off x="457200" y="5239512"/>
+            <a:ext cx="11247120" cy="347472"/>
           </a:xfrm>
           <a:prstGeom prst="rect">
             <a:avLst/>
@@ -6871,12 +6948,89 @@
           <a:p>
             <a:pPr algn="ctr"/>
             <a:r>
-              <a:rPr sz="1500" b="1">
+              <a:rPr sz="1400" b="1">
                 <a:solidFill>
                   <a:srgbClr val="00FF88"/>
                 </a:solidFill>
               </a:rPr>
               <a:t>Zero false positives on normal traffic.  All 3 attack types detected with correct severity.</a:t>
+            </a:r>
+          </a:p>
+        </p:txBody>
+      </p:sp>
+      <p:sp>
+        <p:nvSpPr>
+          <p:cNvPr id="36" name="Rectangle 35"/>
+          <p:cNvSpPr/>
+          <p:nvPr/>
+        </p:nvSpPr>
+        <p:spPr>
+          <a:xfrm>
+            <a:off x="365760" y="5669280"/>
+            <a:ext cx="11430000" cy="548640"/>
+          </a:xfrm>
+          <a:prstGeom prst="rect">
+            <a:avLst/>
+          </a:prstGeom>
+          <a:solidFill>
+            <a:srgbClr val="002040"/>
+          </a:solidFill>
+          <a:ln>
+            <a:noFill/>
+          </a:ln>
+        </p:spPr>
+        <p:style>
+          <a:lnRef idx="1">
+            <a:schemeClr val="accent1"/>
+          </a:lnRef>
+          <a:fillRef idx="3">
+            <a:schemeClr val="accent1"/>
+          </a:fillRef>
+          <a:effectRef idx="2">
+            <a:schemeClr val="accent1"/>
+          </a:effectRef>
+          <a:fontRef idx="minor">
+            <a:schemeClr val="lt1"/>
+          </a:fontRef>
+        </p:style>
+        <p:txBody>
+          <a:bodyPr rtlCol="0" anchor="ctr"/>
+          <a:lstStyle/>
+          <a:p>
+            <a:pPr algn="ctr"/>
+          </a:p>
+        </p:txBody>
+      </p:sp>
+      <p:sp>
+        <p:nvSpPr>
+          <p:cNvPr id="37" name="TextBox 36"/>
+          <p:cNvSpPr txBox="1"/>
+          <p:nvPr/>
+        </p:nvSpPr>
+        <p:spPr>
+          <a:xfrm>
+            <a:off x="457200" y="5696712"/>
+            <a:ext cx="11247120" cy="457200"/>
+          </a:xfrm>
+          <a:prstGeom prst="rect">
+            <a:avLst/>
+          </a:prstGeom>
+          <a:noFill/>
+        </p:spPr>
+        <p:txBody>
+          <a:bodyPr wrap="square">
+            <a:spAutoFit/>
+          </a:bodyPr>
+          <a:lstStyle/>
+          <a:p>
+            <a:pPr algn="ctr"/>
+            <a:r>
+              <a:rPr sz="1400" b="1">
+                <a:solidFill>
+                  <a:srgbClr val="00FF88"/>
+                </a:solidFill>
+              </a:rPr>
+              <a:t>Try live:  https://mdghufran-iot-fingerprinting.hf.space/docs  →  POST /anomaly/score  &amp;  POST /analyze</a:t>
             </a:r>
           </a:p>
         </p:txBody>

</xml_diff>